<commit_message>
Stop slide 37 showing times that divide to a different speedup
The slide displayed 0.288s to 0.215s per object under a 1.33x headline. Those
divide to 1.34x. The 1.33x is the mean of four runs and is the right number to
lead with; 1.34x is job 56908464 alone, which is where the two per-object times
come from. Presented together they looked like an arithmetic error.

Both figures now appear with what each one measures, so the slide can be checked
on its own terms.

Also verified after regeneration: all 51 page numbers match their position, no
shape past the slide edge, and nothing estimated to overflow or collide beyond
0.05in, which is inside the error of a character-width estimate.

Co-Authored-By: Claude Opus 5 <noreply@anthropic.com>
</commit_message>
<xml_diff>
--- a/slides.pptx
+++ b/slides.pptx
@@ -24691,7 +24691,7 @@
                 </a:solidFill>
                 <a:latin typeface="Calibri"/>
               </a:rPr>
-              <a:t>0.288s to 0.215s per object</a:t>
+              <a:t>Range 1.28 to 1.39x, so a 33% gain against an 8% spread</a:t>
             </a:r>
           </a:p>
         </p:txBody>
@@ -24769,7 +24769,7 @@
                 </a:solidFill>
                 <a:latin typeface="Calibri"/>
               </a:rPr>
-              <a:t>Range 1.28 to 1.39x, so a 33% gain against an 8% spread</a:t>
+              <a:t>One job: 0.288s to 0.215s per object, which is 1.34x on its own</a:t>
             </a:r>
           </a:p>
         </p:txBody>

</xml_diff>